<commit_message>
Add measured 100k-step experiment evidence and results-filled assignment PPT
</commit_message>
<xml_diff>
--- a/submission/DRL_PlayingAtari_GroupPENDING.pptx
+++ b/submission/DRL_PlayingAtari_GroupPENDING.pptx
@@ -5086,7 +5086,7 @@
         <p:spPr>
           <a:xfrm>
             <a:off x="594360" y="1463040"/>
-            <a:ext cx="10972800" cy="4480560"/>
+            <a:ext cx="4937760" cy="4480560"/>
           </a:xfrm>
           <a:prstGeom prst="rect">
             <a:avLst/>
@@ -5103,7 +5103,7 @@
               <a:spcAft>
                 <a:spcPts val="1200"/>
               </a:spcAft>
-              <a:defRPr sz="2400">
+              <a:defRPr sz="2200">
                 <a:solidFill>
                   <a:srgbClr val="F0F4FA"/>
                 </a:solidFill>
@@ -5119,7 +5119,7 @@
               <a:spcAft>
                 <a:spcPts val="1200"/>
               </a:spcAft>
-              <a:defRPr sz="2400">
+              <a:defRPr sz="2200">
                 <a:solidFill>
                   <a:srgbClr val="F0F4FA"/>
                 </a:solidFill>
@@ -5135,7 +5135,7 @@
               <a:spcAft>
                 <a:spcPts val="1200"/>
               </a:spcAft>
-              <a:defRPr sz="2400">
+              <a:defRPr sz="2200">
                 <a:solidFill>
                   <a:srgbClr val="F0F4FA"/>
                 </a:solidFill>
@@ -5151,7 +5151,7 @@
               <a:spcAft>
                 <a:spcPts val="1200"/>
               </a:spcAft>
-              <a:defRPr sz="2400">
+              <a:defRPr sz="2200">
                 <a:solidFill>
                   <a:srgbClr val="F0F4FA"/>
                 </a:solidFill>
@@ -5164,9 +5164,33 @@
           </a:p>
         </p:txBody>
       </p:sp>
-      <p:sp>
-        <p:nvSpPr>
-          <p:cNvPr id="4" name="TextBox 3"/>
+      <p:pic>
+        <p:nvPicPr>
+          <p:cNvPr id="4" name="Picture 3" descr="frame_stack.png"/>
+          <p:cNvPicPr>
+            <a:picLocks noChangeAspect="1"/>
+          </p:cNvPicPr>
+          <p:nvPr/>
+        </p:nvPicPr>
+        <p:blipFill>
+          <a:blip r:embed="rId2"/>
+          <a:stretch>
+            <a:fillRect/>
+          </a:stretch>
+        </p:blipFill>
+        <p:spPr>
+          <a:xfrm>
+            <a:off x="5806440" y="1737360"/>
+            <a:ext cx="5669280" cy="1700784"/>
+          </a:xfrm>
+          <a:prstGeom prst="rect">
+            <a:avLst/>
+          </a:prstGeom>
+        </p:spPr>
+      </p:pic>
+      <p:sp>
+        <p:nvSpPr>
+          <p:cNvPr id="5" name="TextBox 4"/>
           <p:cNvSpPr txBox="1"/>
           <p:nvPr/>
         </p:nvSpPr>
@@ -6121,7 +6145,7 @@
         <p:spPr>
           <a:xfrm>
             <a:off x="594360" y="1463040"/>
-            <a:ext cx="10972800" cy="4480560"/>
+            <a:ext cx="4937760" cy="4480560"/>
           </a:xfrm>
           <a:prstGeom prst="rect">
             <a:avLst/>
@@ -6138,7 +6162,7 @@
               <a:spcAft>
                 <a:spcPts val="1200"/>
               </a:spcAft>
-              <a:defRPr sz="2400">
+              <a:defRPr sz="2200">
                 <a:solidFill>
                   <a:srgbClr val="F0F4FA"/>
                 </a:solidFill>
@@ -6146,15 +6170,15 @@
               </a:defRPr>
             </a:pPr>
             <a:r>
-              <a:t>PENDING: run training and evaluation.</a:t>
-            </a:r>
-          </a:p>
-          <a:p>
-            <a:pPr>
-              <a:spcAft>
-                <a:spcPts val="1200"/>
-              </a:spcAft>
-              <a:defRPr sz="2400">
+              <a:t>random: mean=1.20; sample SD=1.6193277068654823; n=10</a:t>
+            </a:r>
+          </a:p>
+          <a:p>
+            <a:pPr>
+              <a:spcAft>
+                <a:spcPts val="1200"/>
+              </a:spcAft>
+              <a:defRPr sz="2200">
                 <a:solidFill>
                   <a:srgbClr val="F0F4FA"/>
                 </a:solidFill>
@@ -6162,15 +6186,15 @@
               </a:defRPr>
             </a:pPr>
             <a:r>
-              <a:t>No scores have been invented.</a:t>
-            </a:r>
-          </a:p>
-          <a:p>
-            <a:pPr>
-              <a:spcAft>
-                <a:spcPts val="1200"/>
-              </a:spcAft>
-              <a:defRPr sz="2400">
+              <a:t>trained: mean=0.40; sample SD=0.6992058987801011; n=10</a:t>
+            </a:r>
+          </a:p>
+          <a:p>
+            <a:pPr>
+              <a:spcAft>
+                <a:spcPts val="1200"/>
+              </a:spcAft>
+              <a:defRPr sz="2200">
                 <a:solidFill>
                   <a:srgbClr val="F0F4FA"/>
                 </a:solidFill>
@@ -6178,15 +6202,15 @@
               </a:defRPr>
             </a:pPr>
             <a:r>
-              <a:t>Show original score curves, evaluation mean/SD and gameplay.</a:t>
-            </a:r>
-          </a:p>
-          <a:p>
-            <a:pPr>
-              <a:spcAft>
-                <a:spcPts val="1200"/>
-              </a:spcAft>
-              <a:defRPr sz="2400">
+              <a:t>Compare evaluated scores, not TD loss alone.</a:t>
+            </a:r>
+          </a:p>
+          <a:p>
+            <a:pPr>
+              <a:spcAft>
+                <a:spcPts val="1200"/>
+              </a:spcAft>
+              <a:defRPr sz="2200">
                 <a:solidFill>
                   <a:srgbClr val="F0F4FA"/>
                 </a:solidFill>
@@ -6194,14 +6218,70 @@
               </a:defRPr>
             </a:pPr>
             <a:r>
-              <a:t>If performance does not improve, report that observation honestly.</a:t>
-            </a:r>
-          </a:p>
-        </p:txBody>
-      </p:sp>
-      <p:sp>
-        <p:nvSpPr>
-          <p:cNvPr id="4" name="TextBox 3"/>
+              <a:t>Small sample; no full benchmark reproduction claim.</a:t>
+            </a:r>
+          </a:p>
+          <a:p>
+            <a:pPr>
+              <a:spcAft>
+                <a:spcPts val="1200"/>
+              </a:spcAft>
+              <a:defRPr sz="2200">
+                <a:solidFill>
+                  <a:srgbClr val="F0F4FA"/>
+                </a:solidFill>
+                <a:latin typeface="Aptos"/>
+              </a:defRPr>
+            </a:pPr>
+            <a:r>
+              <a:t>This run did not demonstrate improvement over random play.</a:t>
+            </a:r>
+          </a:p>
+          <a:p>
+            <a:pPr>
+              <a:spcAft>
+                <a:spcPts val="1200"/>
+              </a:spcAft>
+              <a:defRPr sz="2200">
+                <a:solidFill>
+                  <a:srgbClr val="F0F4FA"/>
+                </a:solidFill>
+                <a:latin typeface="Aptos"/>
+              </a:defRPr>
+            </a:pPr>
+            <a:r>
+              <a:t>Completed steps: 100000; updates: 24751.</a:t>
+            </a:r>
+          </a:p>
+        </p:txBody>
+      </p:sp>
+      <p:pic>
+        <p:nvPicPr>
+          <p:cNvPr id="4" name="Picture 3" descr="comparison.png"/>
+          <p:cNvPicPr>
+            <a:picLocks noChangeAspect="1"/>
+          </p:cNvPicPr>
+          <p:nvPr/>
+        </p:nvPicPr>
+        <p:blipFill>
+          <a:blip r:embed="rId2"/>
+          <a:stretch>
+            <a:fillRect/>
+          </a:stretch>
+        </p:blipFill>
+        <p:spPr>
+          <a:xfrm>
+            <a:off x="5806440" y="1737360"/>
+            <a:ext cx="5669280" cy="3779520"/>
+          </a:xfrm>
+          <a:prstGeom prst="rect">
+            <a:avLst/>
+          </a:prstGeom>
+        </p:spPr>
+      </p:pic>
+      <p:sp>
+        <p:nvSpPr>
+          <p:cNvPr id="5" name="TextBox 4"/>
           <p:cNvSpPr txBox="1"/>
           <p:nvPr/>
         </p:nvSpPr>

</xml_diff>

<commit_message>
Simplify README, code comments and presentation wording
</commit_message>
<xml_diff>
--- a/submission/DRL_PlayingAtari_GroupPENDING.pptx
+++ b/submission/DRL_PlayingAtari_GroupPENDING.pptx
@@ -4379,7 +4379,7 @@
               </a:defRPr>
             </a:pPr>
             <a:r>
-              <a:t>Educational DQN demonstration + paper analysis</a:t>
+              <a:t>Paper review and Breakout experiment</a:t>
             </a:r>
           </a:p>
         </p:txBody>
@@ -4418,7 +4418,7 @@
               </a:defRPr>
             </a:pPr>
             <a:r>
-              <a:t>01   |   Our implementation / supplied assignment brief</a:t>
+              <a:t>01   |   Submission details and references</a:t>
             </a:r>
           </a:p>
         </p:txBody>
@@ -4522,7 +4522,7 @@
               </a:defRPr>
             </a:pPr>
             <a:r>
-              <a:t>Member 1: PENDING actual work + evidence</a:t>
+              <a:t>Member 1: add actual contribution and supporting evidence.</a:t>
             </a:r>
           </a:p>
           <a:p>
@@ -4538,7 +4538,7 @@
               </a:defRPr>
             </a:pPr>
             <a:r>
-              <a:t>Member 2: PENDING actual work + evidence</a:t>
+              <a:t>Member 2: add actual contribution and supporting evidence.</a:t>
             </a:r>
           </a:p>
           <a:p>
@@ -4554,7 +4554,7 @@
               </a:defRPr>
             </a:pPr>
             <a:r>
-              <a:t>Member 3: PENDING actual work + evidence</a:t>
+              <a:t>Member 3: add actual contribution and supporting evidence.</a:t>
             </a:r>
           </a:p>
           <a:p>
@@ -4570,7 +4570,7 @@
               </a:defRPr>
             </a:pPr>
             <a:r>
-              <a:t>Member 4: PENDING actual work + evidence</a:t>
+              <a:t>Member 4: add actual contribution and supporting evidence.</a:t>
             </a:r>
           </a:p>
           <a:p>
@@ -4586,7 +4586,7 @@
               </a:defRPr>
             </a:pPr>
             <a:r>
-              <a:t>Show named commits, screenshots, run logs and speaking contributions.</a:t>
+              <a:t>Include relevant commits, screenshots or run logs and each member’s explanation.</a:t>
             </a:r>
           </a:p>
         </p:txBody>
@@ -4625,7 +4625,7 @@
               </a:defRPr>
             </a:pPr>
             <a:r>
-              <a:t>10   |   Our implementation / supplied assignment brief</a:t>
+              <a:t>10   |   Submission details and references</a:t>
             </a:r>
           </a:p>
         </p:txBody>
@@ -4832,7 +4832,7 @@
               </a:defRPr>
             </a:pPr>
             <a:r>
-              <a:t>11   |   Our implementation / supplied assignment brief</a:t>
+              <a:t>11   |   Submission details and references</a:t>
             </a:r>
           </a:p>
         </p:txBody>
@@ -4936,7 +4936,7 @@
               </a:defRPr>
             </a:pPr>
             <a:r>
-              <a:t>Objective: learn useful actions from pixels and reward.</a:t>
+              <a:t>Learn which actions to take from game screens and rewards.</a:t>
             </a:r>
           </a:p>
           <a:p>
@@ -4952,7 +4952,7 @@
               </a:defRPr>
             </a:pPr>
             <a:r>
-              <a:t>Challenge: rewards can be delayed; consecutive observations are correlated.</a:t>
+              <a:t>Rewards can be delayed, and nearby frames are very similar.</a:t>
             </a:r>
           </a:p>
           <a:p>
@@ -4968,7 +4968,7 @@
               </a:defRPr>
             </a:pPr>
             <a:r>
-              <a:t>Motivation: avoid hand-designed features for every game.</a:t>
+              <a:t>A CNN learns image features instead of requiring features designed for each game.</a:t>
             </a:r>
           </a:p>
         </p:txBody>
@@ -5111,7 +5111,7 @@
               </a:defRPr>
             </a:pPr>
             <a:r>
-              <a:t>Grayscale → 84×84 → stack four recent frames.</a:t>
+              <a:t>Convert to grayscale, resize to 84×84 and stack four frames.</a:t>
             </a:r>
           </a:p>
           <a:p>
@@ -5127,7 +5127,7 @@
               </a:defRPr>
             </a:pPr>
             <a:r>
-              <a:t>Conv: 16 filters → Conv: 32 filters → 256-unit hidden layer.</a:t>
+              <a:t>Two convolutional layers: 16 and 32 filters; hidden layer: 256 units.</a:t>
             </a:r>
           </a:p>
           <a:p>
@@ -5143,7 +5143,7 @@
               </a:defRPr>
             </a:pPr>
             <a:r>
-              <a:t>Output: one unrestricted Q-value per action.</a:t>
+              <a:t>The output gives a Q-value for each action.</a:t>
             </a:r>
           </a:p>
           <a:p>
@@ -5159,7 +5159,7 @@
               </a:defRPr>
             </a:pPr>
             <a:r>
-              <a:t>One frame hides motion; multiple frames provide movement cues.</a:t>
+              <a:t>Four frames help the network infer the ball’s direction.</a:t>
             </a:r>
           </a:p>
         </p:txBody>
@@ -5326,7 +5326,7 @@
               </a:defRPr>
             </a:pPr>
             <a:r>
-              <a:t>Explore with epsilon-greedy actions.</a:t>
+              <a:t>Choose actions using epsilon-greedy exploration.</a:t>
             </a:r>
           </a:p>
           <a:p>
@@ -5342,7 +5342,7 @@
               </a:defRPr>
             </a:pPr>
             <a:r>
-              <a:t>Store (state, action, reward, next state, terminal) in replay.</a:t>
+              <a:t>Store state, action, reward, next state and termination in replay.</a:t>
             </a:r>
           </a:p>
           <a:p>
@@ -5358,7 +5358,7 @@
               </a:defRPr>
             </a:pPr>
             <a:r>
-              <a:t>Sample experiences uniformly; reuse older interactions.</a:t>
+              <a:t>Sample random batches from stored transitions.</a:t>
             </a:r>
           </a:p>
           <a:p>
@@ -5374,7 +5374,7 @@
               </a:defRPr>
             </a:pPr>
             <a:r>
-              <a:t>Fit Q(state, chosen action) to a detached TD target.</a:t>
+              <a:t>Calculate the TD target without gradients, then update the network.</a:t>
             </a:r>
           </a:p>
           <a:p>
@@ -5390,7 +5390,7 @@
               </a:defRPr>
             </a:pPr>
             <a:r>
-              <a:t>Same network supplies next-state values; no periodic target copy.</a:t>
+              <a:t>The same network predicts next-state values, as in the 2013 algorithm.</a:t>
             </a:r>
           </a:p>
         </p:txBody>
@@ -5429,7 +5429,7 @@
               </a:defRPr>
             </a:pPr>
             <a:r>
-              <a:t>04   |   Our implementation / supplied assignment brief</a:t>
+              <a:t>04   |   Breakout implementation and experiment</a:t>
             </a:r>
           </a:p>
         </p:txBody>
@@ -5636,7 +5636,7 @@
               </a:defRPr>
             </a:pPr>
             <a:r>
-              <a:t>05   |   Our implementation / supplied assignment brief</a:t>
+              <a:t>05   |   Breakout implementation and experiment</a:t>
             </a:r>
           </a:p>
         </p:txBody>
@@ -5963,7 +5963,7 @@
               </a:defRPr>
             </a:pPr>
             <a:r>
-              <a:t>Breakout only; reduced budget specified in config/breakout.json.</a:t>
+              <a:t>Breakout; 100,000 agent steps. Settings are in src/train.py.</a:t>
             </a:r>
           </a:p>
           <a:p>
@@ -5979,7 +5979,7 @@
               </a:defRPr>
             </a:pPr>
             <a:r>
-              <a:t>Replay 5,000; batch 32; gamma 0.99; RMSprop; MSE.</a:t>
+              <a:t>Replay capacity: 5,000; batch: 32; gamma: 0.99; RMSprop; MSE.</a:t>
             </a:r>
           </a:p>
           <a:p>
@@ -5995,7 +5995,7 @@
               </a:defRPr>
             </a:pPr>
             <a:r>
-              <a:t>Clip training rewards; report original game scores.</a:t>
+              <a:t>Clip rewards for training, but report the original scores.</a:t>
             </a:r>
           </a:p>
           <a:p>
@@ -6011,7 +6011,7 @@
               </a:defRPr>
             </a:pPr>
             <a:r>
-              <a:t>Evaluate random and trained policies on matching seeds.</a:t>
+              <a:t>Evaluate random and trained policies using the same ten environment seeds.</a:t>
             </a:r>
           </a:p>
           <a:p>
@@ -6027,7 +6027,7 @@
               </a:defRPr>
             </a:pPr>
             <a:r>
-              <a:t>Record versions, checkpoint, CSV logs and gameplay.</a:t>
+              <a:t>Save the checkpoint, logs, plots and gameplay clips.</a:t>
             </a:r>
           </a:p>
         </p:txBody>
@@ -6066,7 +6066,7 @@
               </a:defRPr>
             </a:pPr>
             <a:r>
-              <a:t>07   |   Our implementation / supplied assignment brief</a:t>
+              <a:t>07   |   Breakout implementation and experiment</a:t>
             </a:r>
           </a:p>
         </p:txBody>
@@ -6170,7 +6170,7 @@
               </a:defRPr>
             </a:pPr>
             <a:r>
-              <a:t>random: mean=1.20; sample SD=1.6193277068654823; n=10</a:t>
+              <a:t>Random: mean score 1.20; sample SD 1.62; 10 episodes.</a:t>
             </a:r>
           </a:p>
           <a:p>
@@ -6186,7 +6186,7 @@
               </a:defRPr>
             </a:pPr>
             <a:r>
-              <a:t>trained: mean=0.40; sample SD=0.6992058987801011; n=10</a:t>
+              <a:t>Trained: mean score 0.40; sample SD 0.70; 10 episodes.</a:t>
             </a:r>
           </a:p>
           <a:p>
@@ -6202,7 +6202,7 @@
               </a:defRPr>
             </a:pPr>
             <a:r>
-              <a:t>Compare evaluated scores, not TD loss alone.</a:t>
+              <a:t>The trained policy did not outperform random play in this run.</a:t>
             </a:r>
           </a:p>
           <a:p>
@@ -6218,7 +6218,7 @@
               </a:defRPr>
             </a:pPr>
             <a:r>
-              <a:t>Small sample; no full benchmark reproduction claim.</a:t>
+              <a:t>Training completed 100,000 agent steps and 24,751 updates.</a:t>
             </a:r>
           </a:p>
           <a:p>
@@ -6234,7 +6234,7 @@
               </a:defRPr>
             </a:pPr>
             <a:r>
-              <a:t>This run did not demonstrate improvement over random play.</a:t>
+              <a:t>Changes in TD loss do not establish better gameplay.</a:t>
             </a:r>
           </a:p>
           <a:p>
@@ -6250,7 +6250,7 @@
               </a:defRPr>
             </a:pPr>
             <a:r>
-              <a:t>Completed steps: 100000; updates: 24751.</a:t>
+              <a:t>Ten episodes provide limited evidence; this is not a full benchmark reproduction.</a:t>
             </a:r>
           </a:p>
         </p:txBody>
@@ -6313,7 +6313,7 @@
               </a:defRPr>
             </a:pPr>
             <a:r>
-              <a:t>08   |   Our implementation / supplied assignment brief</a:t>
+              <a:t>08   |   Breakout implementation and experiment</a:t>
             </a:r>
           </a:p>
         </p:txBody>
@@ -6417,7 +6417,7 @@
               </a:defRPr>
             </a:pPr>
             <a:r>
-              <a:t>Limitations: short run, one game, small replay and modern preprocessing.</a:t>
+              <a:t>Limits: one game, a short run, small replay and different preprocessing.</a:t>
             </a:r>
           </a:p>
           <a:p>
@@ -6433,7 +6433,7 @@
               </a:defRPr>
             </a:pPr>
             <a:r>
-              <a:t>Sparse feedback and long-horizon decisions remain difficult.</a:t>
+              <a:t>The code trains and evaluates, but this run did not show improved scores.</a:t>
             </a:r>
           </a:p>
           <a:p>
@@ -6449,7 +6449,7 @@
               </a:defRPr>
             </a:pPr>
             <a:r>
-              <a:t>Future experiment: longer budgets, multiple training seeds and replay ablation.</a:t>
+              <a:t>Next checks: longer runs, several training seeds and different replay sizes.</a:t>
             </a:r>
           </a:p>
           <a:p>
@@ -6465,7 +6465,7 @@
               </a:defRPr>
             </a:pPr>
             <a:r>
-              <a:t>Later extensions: target network / Double DQN, clearly labelled separately.</a:t>
+              <a:t>A target network or Double DQN would be a separately labelled extension.</a:t>
             </a:r>
           </a:p>
           <a:p>
@@ -6481,7 +6481,7 @@
               </a:defRPr>
             </a:pPr>
             <a:r>
-              <a:t>Conclusion: demonstrate the complete learning pipeline; assess actual policy scores.</a:t>
+              <a:t>Compare evaluation scores before claiming improved performance.</a:t>
             </a:r>
           </a:p>
         </p:txBody>
@@ -6520,7 +6520,7 @@
               </a:defRPr>
             </a:pPr>
             <a:r>
-              <a:t>09   |   Our implementation / supplied assignment brief</a:t>
+              <a:t>09   |   Breakout implementation and experiment</a:t>
             </a:r>
           </a:p>
         </p:txBody>

</xml_diff>